<commit_message>
Add the team's photos to the diagram slide
Phone photo in the "Phone or PC" card, server racks (darkened) behind the
data center, a cooling-tower photo whose vapor arrow rises to the clouds,
and a desalination-plant photo in a slightly wider desalination card.
Notes now say the big round tower is power-plant style and that
data-center cooling towers work the same way.

Co-Authored-By: Claude Opus 5.5 <noreply@anthropic.com>
Claude-Session: https://claude.ai/code/session_01D1yfgr7znJrRSehnJ7HGe8
</commit_message>
<xml_diff>
--- a/ai-diagram-slide.pptx
+++ b/ai-diagram-slide.pptx
@@ -511,7 +511,7 @@
           <a:p>
             <a:r>
               <a:rPr lang="en-US" dirty="0"/>
-              <a:t>1. You ask a question on your PC. It travels over the internet to a data center, and the answer comes back the same way.</a:t>
+              <a:t>1. You ask a chatbot a question on your phone or PC. It travels over the internet to a data center, and the answer comes back the same way.</a:t>
             </a:r>
           </a:p>
           <a:p>
@@ -563,6 +563,18 @@
             <a:r>
               <a:rPr lang="en-US" dirty="0"/>
               <a:t>Simplified: real water takes days to years to go around the cycle, and the rain does not fall back on the same data center.</a:t>
+            </a:r>
+          </a:p>
+          <a:p>
+            <a:r>
+              <a:rPr lang="en-US" dirty="0"/>
+              <a:t>About the cooling-tower photo: big round towers like this one are mostly at power plants. Data-center cooling towers are smaller boxes, but they work the same way: water evaporates and carries the heat away.</a:t>
+            </a:r>
+          </a:p>
+          <a:p>
+            <a:r>
+              <a:rPr lang="en-US" dirty="0"/>
+              <a:t>Photos: our team's pictures of a phone, server racks (behind the data center), a cooling tower and a desalination plant.</a:t>
             </a:r>
           </a:p>
         </p:txBody>
@@ -1100,38 +1112,9 @@
           </a:p>
         </p:txBody>
       </p:sp>
-      <p:sp>
-        <p:nvSpPr>
-          <p:cNvPr id="5" name="Shape 3"/>
-          <p:cNvSpPr/>
-          <p:nvPr/>
-        </p:nvSpPr>
-        <p:spPr>
-          <a:xfrm>
-            <a:off x="4526280" y="2240280"/>
-            <a:ext cx="4800600" cy="2880360"/>
-          </a:xfrm>
-          <a:prstGeom prst="roundRect">
-            <a:avLst>
-              <a:gd name="adj" fmla="val 5714"/>
-            </a:avLst>
-          </a:prstGeom>
-          <a:solidFill>
-            <a:srgbClr val="0B2239">
-              <a:alpha val="92000"/>
-            </a:srgbClr>
-          </a:solidFill>
-          <a:ln w="28575">
-            <a:solidFill>
-              <a:srgbClr val="C9D6E2"/>
-            </a:solidFill>
-            <a:prstDash val="solid"/>
-          </a:ln>
-        </p:spPr>
-      </p:sp>
       <p:pic>
         <p:nvPicPr>
-          <p:cNvPr id="6" name="Image 0" descr="preencoded.png">    </p:cNvPr>
+          <p:cNvPr id="5" name="Image 0" descr="preencoded.png">    </p:cNvPr>
           <p:cNvPicPr>
             <a:picLocks noChangeAspect="1"/>
           </p:cNvPicPr>
@@ -1145,6 +1128,54 @@
         </p:blipFill>
         <p:spPr>
           <a:xfrm>
+            <a:off x="4526280" y="2240280"/>
+            <a:ext cx="4800600" cy="2880360"/>
+          </a:xfrm>
+          <a:prstGeom prst="rect">
+            <a:avLst/>
+          </a:prstGeom>
+        </p:spPr>
+      </p:pic>
+      <p:sp>
+        <p:nvSpPr>
+          <p:cNvPr id="6" name="Shape 3"/>
+          <p:cNvSpPr/>
+          <p:nvPr/>
+        </p:nvSpPr>
+        <p:spPr>
+          <a:xfrm>
+            <a:off x="4526280" y="2240280"/>
+            <a:ext cx="4800600" cy="2880360"/>
+          </a:xfrm>
+          <a:prstGeom prst="roundRect">
+            <a:avLst>
+              <a:gd name="adj" fmla="val 5714"/>
+            </a:avLst>
+          </a:prstGeom>
+          <a:ln w="28575">
+            <a:solidFill>
+              <a:srgbClr val="C9D6E2"/>
+            </a:solidFill>
+            <a:prstDash val="solid"/>
+          </a:ln>
+        </p:spPr>
+      </p:sp>
+      <p:pic>
+        <p:nvPicPr>
+          <p:cNvPr id="7" name="Image 1" descr="preencoded.png">    </p:cNvPr>
+          <p:cNvPicPr>
+            <a:picLocks noChangeAspect="1"/>
+          </p:cNvPicPr>
+          <p:nvPr/>
+        </p:nvPicPr>
+        <p:blipFill>
+          <a:blip r:embed="rId3"/>
+          <a:stretch>
+            <a:fillRect/>
+          </a:stretch>
+        </p:blipFill>
+        <p:spPr>
+          <a:xfrm>
             <a:off x="4800600" y="2368296"/>
             <a:ext cx="329184" cy="329184"/>
           </a:xfrm>
@@ -1155,7 +1186,7 @@
       </p:pic>
       <p:sp>
         <p:nvSpPr>
-          <p:cNvPr id="7" name="label"/>
+          <p:cNvPr id="8" name="label"/>
           <p:cNvSpPr txBox="1"/>
           <p:nvPr/>
         </p:nvSpPr>
@@ -1194,7 +1225,7 @@
       </p:sp>
       <p:sp>
         <p:nvSpPr>
-          <p:cNvPr id="8" name="Shape 5"/>
+          <p:cNvPr id="9" name="Shape 5"/>
           <p:cNvSpPr/>
           <p:nvPr/>
         </p:nvSpPr>
@@ -1219,7 +1250,7 @@
       </p:sp>
       <p:sp>
         <p:nvSpPr>
-          <p:cNvPr id="9" name="caption-badge"/>
+          <p:cNvPr id="10" name="caption-badge"/>
           <p:cNvSpPr txBox="1"/>
           <p:nvPr/>
         </p:nvSpPr>
@@ -1258,7 +1289,7 @@
       </p:sp>
       <p:sp>
         <p:nvSpPr>
-          <p:cNvPr id="10" name="Shape 7"/>
+          <p:cNvPr id="11" name="Shape 7"/>
           <p:cNvSpPr/>
           <p:nvPr/>
         </p:nvSpPr>
@@ -1298,7 +1329,7 @@
       </p:sp>
       <p:sp>
         <p:nvSpPr>
-          <p:cNvPr id="11" name="Shape 8"/>
+          <p:cNvPr id="12" name="Shape 8"/>
           <p:cNvSpPr/>
           <p:nvPr/>
         </p:nvSpPr>
@@ -1338,7 +1369,7 @@
       </p:sp>
       <p:sp>
         <p:nvSpPr>
-          <p:cNvPr id="12" name="Shape 9"/>
+          <p:cNvPr id="13" name="Shape 9"/>
           <p:cNvSpPr/>
           <p:nvPr/>
         </p:nvSpPr>
@@ -1378,7 +1409,7 @@
       </p:sp>
       <p:sp>
         <p:nvSpPr>
-          <p:cNvPr id="13" name="Shape 10"/>
+          <p:cNvPr id="14" name="Shape 10"/>
           <p:cNvSpPr/>
           <p:nvPr/>
         </p:nvSpPr>
@@ -1418,7 +1449,7 @@
       </p:sp>
       <p:sp>
         <p:nvSpPr>
-          <p:cNvPr id="14" name="caption-loop"/>
+          <p:cNvPr id="15" name="caption-loop"/>
           <p:cNvSpPr txBox="1"/>
           <p:nvPr/>
         </p:nvSpPr>
@@ -1457,7 +1488,7 @@
       </p:sp>
       <p:sp>
         <p:nvSpPr>
-          <p:cNvPr id="15" name="Shape 12"/>
+          <p:cNvPr id="16" name="Shape 12"/>
           <p:cNvSpPr/>
           <p:nvPr/>
         </p:nvSpPr>
@@ -1484,14 +1515,14 @@
       </p:sp>
       <p:pic>
         <p:nvPicPr>
-          <p:cNvPr id="16" name="Image 1" descr="preencoded.png">    </p:cNvPr>
+          <p:cNvPr id="17" name="Image 2" descr="preencoded.png">    </p:cNvPr>
           <p:cNvPicPr>
             <a:picLocks noChangeAspect="1"/>
           </p:cNvPicPr>
           <p:nvPr/>
         </p:nvPicPr>
         <p:blipFill>
-          <a:blip r:embed="rId3"/>
+          <a:blip r:embed="rId4"/>
           <a:stretch>
             <a:fillRect/>
           </a:stretch>
@@ -1508,7 +1539,7 @@
       </p:pic>
       <p:sp>
         <p:nvSpPr>
-          <p:cNvPr id="17" name="label"/>
+          <p:cNvPr id="18" name="label"/>
           <p:cNvSpPr txBox="1"/>
           <p:nvPr/>
         </p:nvSpPr>
@@ -1547,7 +1578,7 @@
       </p:sp>
       <p:sp>
         <p:nvSpPr>
-          <p:cNvPr id="18" name="Shape 14"/>
+          <p:cNvPr id="19" name="Shape 14"/>
           <p:cNvSpPr/>
           <p:nvPr/>
         </p:nvSpPr>
@@ -1574,14 +1605,14 @@
       </p:sp>
       <p:pic>
         <p:nvPicPr>
-          <p:cNvPr id="19" name="Image 2" descr="preencoded.png">    </p:cNvPr>
+          <p:cNvPr id="20" name="Image 3" descr="preencoded.png">    </p:cNvPr>
           <p:cNvPicPr>
             <a:picLocks noChangeAspect="1"/>
           </p:cNvPicPr>
           <p:nvPr/>
         </p:nvPicPr>
         <p:blipFill>
-          <a:blip r:embed="rId4"/>
+          <a:blip r:embed="rId5"/>
           <a:stretch>
             <a:fillRect/>
           </a:stretch>
@@ -1598,7 +1629,7 @@
       </p:pic>
       <p:sp>
         <p:nvSpPr>
-          <p:cNvPr id="20" name="label"/>
+          <p:cNvPr id="21" name="label"/>
           <p:cNvSpPr txBox="1"/>
           <p:nvPr/>
         </p:nvSpPr>
@@ -1637,7 +1668,7 @@
       </p:sp>
       <p:sp>
         <p:nvSpPr>
-          <p:cNvPr id="21" name="Shape 16"/>
+          <p:cNvPr id="22" name="Shape 16"/>
           <p:cNvSpPr/>
           <p:nvPr/>
         </p:nvSpPr>
@@ -1664,14 +1695,14 @@
       </p:sp>
       <p:pic>
         <p:nvPicPr>
-          <p:cNvPr id="22" name="Image 3" descr="preencoded.png">    </p:cNvPr>
+          <p:cNvPr id="23" name="Image 4" descr="preencoded.png">    </p:cNvPr>
           <p:cNvPicPr>
             <a:picLocks noChangeAspect="1"/>
           </p:cNvPicPr>
           <p:nvPr/>
         </p:nvPicPr>
         <p:blipFill>
-          <a:blip r:embed="rId5"/>
+          <a:blip r:embed="rId6"/>
           <a:stretch>
             <a:fillRect/>
           </a:stretch>
@@ -1688,7 +1719,7 @@
       </p:pic>
       <p:sp>
         <p:nvSpPr>
-          <p:cNvPr id="23" name="label"/>
+          <p:cNvPr id="24" name="label"/>
           <p:cNvSpPr txBox="1"/>
           <p:nvPr/>
         </p:nvSpPr>
@@ -1727,7 +1758,7 @@
       </p:sp>
       <p:sp>
         <p:nvSpPr>
-          <p:cNvPr id="24" name="Shape 18"/>
+          <p:cNvPr id="25" name="Shape 18"/>
           <p:cNvSpPr/>
           <p:nvPr/>
         </p:nvSpPr>
@@ -1754,14 +1785,14 @@
       </p:sp>
       <p:pic>
         <p:nvPicPr>
-          <p:cNvPr id="25" name="Image 4" descr="preencoded.png">    </p:cNvPr>
+          <p:cNvPr id="26" name="Image 5" descr="preencoded.png">    </p:cNvPr>
           <p:cNvPicPr>
             <a:picLocks noChangeAspect="1"/>
           </p:cNvPicPr>
           <p:nvPr/>
         </p:nvPicPr>
         <p:blipFill>
-          <a:blip r:embed="rId6"/>
+          <a:blip r:embed="rId7"/>
           <a:stretch>
             <a:fillRect/>
           </a:stretch>
@@ -1778,7 +1809,7 @@
       </p:pic>
       <p:sp>
         <p:nvSpPr>
-          <p:cNvPr id="26" name="label"/>
+          <p:cNvPr id="27" name="label"/>
           <p:cNvSpPr txBox="1"/>
           <p:nvPr/>
         </p:nvSpPr>
@@ -1817,7 +1848,7 @@
       </p:sp>
       <p:sp>
         <p:nvSpPr>
-          <p:cNvPr id="27" name="Shape 20"/>
+          <p:cNvPr id="28" name="Shape 20"/>
           <p:cNvSpPr/>
           <p:nvPr/>
         </p:nvSpPr>
@@ -1842,7 +1873,7 @@
       </p:sp>
       <p:sp>
         <p:nvSpPr>
-          <p:cNvPr id="28" name="caption-badge"/>
+          <p:cNvPr id="29" name="caption-badge"/>
           <p:cNvSpPr txBox="1"/>
           <p:nvPr/>
         </p:nvSpPr>
@@ -1881,7 +1912,7 @@
       </p:sp>
       <p:sp>
         <p:nvSpPr>
-          <p:cNvPr id="29" name="Shape 22"/>
+          <p:cNvPr id="30" name="Shape 22"/>
           <p:cNvSpPr/>
           <p:nvPr/>
         </p:nvSpPr>
@@ -1906,7 +1937,7 @@
       </p:sp>
       <p:sp>
         <p:nvSpPr>
-          <p:cNvPr id="30" name="caption-badge"/>
+          <p:cNvPr id="31" name="caption-badge"/>
           <p:cNvSpPr txBox="1"/>
           <p:nvPr/>
         </p:nvSpPr>
@@ -1945,7 +1976,7 @@
       </p:sp>
       <p:sp>
         <p:nvSpPr>
-          <p:cNvPr id="31" name="Shape 24"/>
+          <p:cNvPr id="32" name="Shape 24"/>
           <p:cNvSpPr/>
           <p:nvPr/>
         </p:nvSpPr>
@@ -1970,7 +2001,7 @@
       </p:sp>
       <p:sp>
         <p:nvSpPr>
-          <p:cNvPr id="32" name="caption-badge"/>
+          <p:cNvPr id="33" name="caption-badge"/>
           <p:cNvSpPr txBox="1"/>
           <p:nvPr/>
         </p:nvSpPr>
@@ -2009,7 +2040,7 @@
       </p:sp>
       <p:sp>
         <p:nvSpPr>
-          <p:cNvPr id="33" name="Shape 26"/>
+          <p:cNvPr id="34" name="Shape 26"/>
           <p:cNvSpPr/>
           <p:nvPr/>
         </p:nvSpPr>
@@ -2038,14 +2069,14 @@
       </p:sp>
       <p:pic>
         <p:nvPicPr>
-          <p:cNvPr id="34" name="Image 5" descr="preencoded.png">    </p:cNvPr>
+          <p:cNvPr id="35" name="Image 6" descr="preencoded.png">    </p:cNvPr>
           <p:cNvPicPr>
             <a:picLocks noChangeAspect="1"/>
           </p:cNvPicPr>
           <p:nvPr/>
         </p:nvPicPr>
         <p:blipFill>
-          <a:blip r:embed="rId7"/>
+          <a:blip r:embed="rId8"/>
           <a:stretch>
             <a:fillRect/>
           </a:stretch>
@@ -2062,7 +2093,7 @@
       </p:pic>
       <p:sp>
         <p:nvSpPr>
-          <p:cNvPr id="35" name="label"/>
+          <p:cNvPr id="36" name="label"/>
           <p:cNvSpPr txBox="1"/>
           <p:nvPr/>
         </p:nvSpPr>
@@ -2101,7 +2132,7 @@
       </p:sp>
       <p:sp>
         <p:nvSpPr>
-          <p:cNvPr id="36" name="caption-sub"/>
+          <p:cNvPr id="37" name="caption-sub"/>
           <p:cNvSpPr txBox="1"/>
           <p:nvPr/>
         </p:nvSpPr>
@@ -2140,7 +2171,7 @@
       </p:sp>
       <p:sp>
         <p:nvSpPr>
-          <p:cNvPr id="37" name="Shape 29"/>
+          <p:cNvPr id="38" name="Shape 29"/>
           <p:cNvSpPr/>
           <p:nvPr/>
         </p:nvSpPr>
@@ -2169,14 +2200,14 @@
       </p:sp>
       <p:pic>
         <p:nvPicPr>
-          <p:cNvPr id="38" name="Image 6" descr="preencoded.png">    </p:cNvPr>
+          <p:cNvPr id="39" name="Image 7" descr="preencoded.png">    </p:cNvPr>
           <p:cNvPicPr>
             <a:picLocks noChangeAspect="1"/>
           </p:cNvPicPr>
           <p:nvPr/>
         </p:nvPicPr>
         <p:blipFill>
-          <a:blip r:embed="rId8"/>
+          <a:blip r:embed="rId9"/>
           <a:stretch>
             <a:fillRect/>
           </a:stretch>
@@ -2193,7 +2224,7 @@
       </p:pic>
       <p:sp>
         <p:nvSpPr>
-          <p:cNvPr id="39" name="label"/>
+          <p:cNvPr id="40" name="label"/>
           <p:cNvSpPr txBox="1"/>
           <p:nvPr/>
         </p:nvSpPr>
@@ -2232,7 +2263,7 @@
       </p:sp>
       <p:sp>
         <p:nvSpPr>
-          <p:cNvPr id="40" name="caption-sub"/>
+          <p:cNvPr id="41" name="caption-sub"/>
           <p:cNvSpPr txBox="1"/>
           <p:nvPr/>
         </p:nvSpPr>
@@ -2269,9 +2300,33 @@
           </a:p>
         </p:txBody>
       </p:sp>
-      <p:sp>
-        <p:nvSpPr>
-          <p:cNvPr id="41" name="Shape 32"/>
+      <p:pic>
+        <p:nvPicPr>
+          <p:cNvPr id="42" name="Image 8" descr="preencoded.png">    </p:cNvPr>
+          <p:cNvPicPr>
+            <a:picLocks noChangeAspect="1"/>
+          </p:cNvPicPr>
+          <p:nvPr/>
+        </p:nvPicPr>
+        <p:blipFill>
+          <a:blip r:embed="rId10"/>
+          <a:stretch>
+            <a:fillRect/>
+          </a:stretch>
+        </p:blipFill>
+        <p:spPr>
+          <a:xfrm>
+            <a:off x="2395728" y="2560320"/>
+            <a:ext cx="1600200" cy="1051560"/>
+          </a:xfrm>
+          <a:prstGeom prst="rect">
+            <a:avLst/>
+          </a:prstGeom>
+        </p:spPr>
+      </p:pic>
+      <p:sp>
+        <p:nvSpPr>
+          <p:cNvPr id="43" name="Shape 32"/>
           <p:cNvSpPr/>
           <p:nvPr/>
         </p:nvSpPr>
@@ -2285,11 +2340,6 @@
               <a:gd name="adj" fmla="val 10435"/>
             </a:avLst>
           </a:prstGeom>
-          <a:solidFill>
-            <a:srgbClr val="0E1B2A">
-              <a:alpha val="90000"/>
-            </a:srgbClr>
-          </a:solidFill>
           <a:ln w="19050">
             <a:solidFill>
               <a:srgbClr val="C9D6E2"/>
@@ -2298,39 +2348,15 @@
           </a:ln>
         </p:spPr>
       </p:sp>
-      <p:pic>
-        <p:nvPicPr>
-          <p:cNvPr id="42" name="Image 7" descr="preencoded.png">    </p:cNvPr>
-          <p:cNvPicPr>
-            <a:picLocks noChangeAspect="1"/>
-          </p:cNvPicPr>
-          <p:nvPr/>
-        </p:nvPicPr>
-        <p:blipFill>
-          <a:blip r:embed="rId9"/>
-          <a:stretch>
-            <a:fillRect/>
-          </a:stretch>
-        </p:blipFill>
-        <p:spPr>
-          <a:xfrm>
-            <a:off x="2985516" y="2651760"/>
-            <a:ext cx="420624" cy="420624"/>
-          </a:xfrm>
-          <a:prstGeom prst="rect">
-            <a:avLst/>
-          </a:prstGeom>
-        </p:spPr>
-      </p:pic>
-      <p:sp>
-        <p:nvSpPr>
-          <p:cNvPr id="43" name="label"/>
+      <p:sp>
+        <p:nvSpPr>
+          <p:cNvPr id="44" name="label"/>
           <p:cNvSpPr txBox="1"/>
           <p:nvPr/>
         </p:nvSpPr>
         <p:spPr>
           <a:xfrm>
-            <a:off x="2395728" y="3090672"/>
+            <a:off x="2395728" y="3236976"/>
             <a:ext cx="1600200" cy="329184"/>
           </a:xfrm>
           <a:prstGeom prst="rect">
@@ -2355,7 +2381,7 @@
                 <a:ea typeface="Calibri" pitchFamily="34" charset="-122"/>
                 <a:cs typeface="Calibri" pitchFamily="34" charset="-120"/>
               </a:rPr>
-              <a:t>Your PC</a:t>
+              <a:t>Phone or PC</a:t>
             </a:r>
             <a:endParaRPr lang="en-US" sz="2000" dirty="0"/>
           </a:p>
@@ -2363,7 +2389,7 @@
       </p:sp>
       <p:sp>
         <p:nvSpPr>
-          <p:cNvPr id="44" name="caption-sub"/>
+          <p:cNvPr id="45" name="caption-sub"/>
           <p:cNvSpPr txBox="1"/>
           <p:nvPr/>
         </p:nvSpPr>
@@ -2402,7 +2428,7 @@
       </p:sp>
       <p:sp>
         <p:nvSpPr>
-          <p:cNvPr id="45" name="Shape 35"/>
+          <p:cNvPr id="46" name="Shape 35"/>
           <p:cNvSpPr/>
           <p:nvPr/>
         </p:nvSpPr>
@@ -2427,7 +2453,7 @@
       </p:sp>
       <p:sp>
         <p:nvSpPr>
-          <p:cNvPr id="46" name="caption-badge"/>
+          <p:cNvPr id="47" name="caption-badge"/>
           <p:cNvSpPr txBox="1"/>
           <p:nvPr/>
         </p:nvSpPr>
@@ -2466,7 +2492,7 @@
       </p:sp>
       <p:sp>
         <p:nvSpPr>
-          <p:cNvPr id="47" name="Shape 37"/>
+          <p:cNvPr id="48" name="Shape 37"/>
           <p:cNvSpPr/>
           <p:nvPr/>
         </p:nvSpPr>
@@ -2505,7 +2531,7 @@
       </p:sp>
       <p:sp>
         <p:nvSpPr>
-          <p:cNvPr id="48" name="caption-arrow"/>
+          <p:cNvPr id="49" name="caption-arrow"/>
           <p:cNvSpPr txBox="1"/>
           <p:nvPr/>
         </p:nvSpPr>
@@ -2544,7 +2570,7 @@
       </p:sp>
       <p:sp>
         <p:nvSpPr>
-          <p:cNvPr id="49" name="Shape 39"/>
+          <p:cNvPr id="50" name="Shape 39"/>
           <p:cNvSpPr/>
           <p:nvPr/>
         </p:nvSpPr>
@@ -2582,7 +2608,7 @@
       </p:sp>
       <p:sp>
         <p:nvSpPr>
-          <p:cNvPr id="50" name="caption-arrow"/>
+          <p:cNvPr id="51" name="caption-arrow"/>
           <p:cNvSpPr txBox="1"/>
           <p:nvPr/>
         </p:nvSpPr>
@@ -2621,7 +2647,7 @@
       </p:sp>
       <p:sp>
         <p:nvSpPr>
-          <p:cNvPr id="51" name="Shape 41"/>
+          <p:cNvPr id="52" name="Shape 41"/>
           <p:cNvSpPr/>
           <p:nvPr/>
         </p:nvSpPr>
@@ -2659,7 +2685,7 @@
       </p:sp>
       <p:sp>
         <p:nvSpPr>
-          <p:cNvPr id="52" name="caption-arrow"/>
+          <p:cNvPr id="53" name="caption-arrow"/>
           <p:cNvSpPr txBox="1"/>
           <p:nvPr/>
         </p:nvSpPr>
@@ -2698,30 +2724,6 @@
       </p:sp>
       <p:pic>
         <p:nvPicPr>
-          <p:cNvPr id="53" name="Image 8" descr="preencoded.png">    </p:cNvPr>
-          <p:cNvPicPr>
-            <a:picLocks noChangeAspect="1"/>
-          </p:cNvPicPr>
-          <p:nvPr/>
-        </p:nvPicPr>
-        <p:blipFill>
-          <a:blip r:embed="rId10"/>
-          <a:stretch>
-            <a:fillRect/>
-          </a:stretch>
-        </p:blipFill>
-        <p:spPr>
-          <a:xfrm>
-            <a:off x="2258568" y="3776472"/>
-            <a:ext cx="256032" cy="256032"/>
-          </a:xfrm>
-          <a:prstGeom prst="rect">
-            <a:avLst/>
-          </a:prstGeom>
-        </p:spPr>
-      </p:pic>
-      <p:pic>
-        <p:nvPicPr>
           <p:cNvPr id="54" name="Image 9" descr="preencoded.png">    </p:cNvPr>
           <p:cNvPicPr>
             <a:picLocks noChangeAspect="1"/>
@@ -2736,6 +2738,30 @@
         </p:blipFill>
         <p:spPr>
           <a:xfrm>
+            <a:off x="2258568" y="3776472"/>
+            <a:ext cx="256032" cy="256032"/>
+          </a:xfrm>
+          <a:prstGeom prst="rect">
+            <a:avLst/>
+          </a:prstGeom>
+        </p:spPr>
+      </p:pic>
+      <p:pic>
+        <p:nvPicPr>
+          <p:cNvPr id="55" name="Image 10" descr="preencoded.png">    </p:cNvPr>
+          <p:cNvPicPr>
+            <a:picLocks noChangeAspect="1"/>
+          </p:cNvPicPr>
+          <p:nvPr/>
+        </p:nvPicPr>
+        <p:blipFill>
+          <a:blip r:embed="rId12"/>
+          <a:stretch>
+            <a:fillRect/>
+          </a:stretch>
+        </p:blipFill>
+        <p:spPr>
+          <a:xfrm>
             <a:off x="10012680" y="566928"/>
             <a:ext cx="868680" cy="868680"/>
           </a:xfrm>
@@ -2746,7 +2772,7 @@
       </p:pic>
       <p:sp>
         <p:nvSpPr>
-          <p:cNvPr id="55" name="label"/>
+          <p:cNvPr id="56" name="label"/>
           <p:cNvSpPr txBox="1"/>
           <p:nvPr/>
         </p:nvSpPr>
@@ -2785,7 +2811,7 @@
       </p:sp>
       <p:sp>
         <p:nvSpPr>
-          <p:cNvPr id="56" name="Shape 44"/>
+          <p:cNvPr id="57" name="Shape 44"/>
           <p:cNvSpPr/>
           <p:nvPr/>
         </p:nvSpPr>
@@ -2810,7 +2836,7 @@
       </p:sp>
       <p:sp>
         <p:nvSpPr>
-          <p:cNvPr id="57" name="caption-badge"/>
+          <p:cNvPr id="58" name="caption-badge"/>
           <p:cNvSpPr txBox="1"/>
           <p:nvPr/>
         </p:nvSpPr>
@@ -2847,16 +2873,64 @@
           </a:p>
         </p:txBody>
       </p:sp>
-      <p:sp>
-        <p:nvSpPr>
-          <p:cNvPr id="58" name="Shape 46"/>
+      <p:pic>
+        <p:nvPicPr>
+          <p:cNvPr id="59" name="Image 11" descr="preencoded.png">    </p:cNvPr>
+          <p:cNvPicPr>
+            <a:picLocks noChangeAspect="1"/>
+          </p:cNvPicPr>
+          <p:nvPr/>
+        </p:nvPicPr>
+        <p:blipFill>
+          <a:blip r:embed="rId13"/>
+          <a:stretch>
+            <a:fillRect/>
+          </a:stretch>
+        </p:blipFill>
+        <p:spPr>
+          <a:xfrm>
+            <a:off x="9390888" y="2377440"/>
+            <a:ext cx="914400" cy="2148840"/>
+          </a:xfrm>
+          <a:prstGeom prst="rect">
+            <a:avLst/>
+          </a:prstGeom>
+        </p:spPr>
+      </p:pic>
+      <p:sp>
+        <p:nvSpPr>
+          <p:cNvPr id="60" name="Shape 46"/>
           <p:cNvSpPr/>
           <p:nvPr/>
         </p:nvSpPr>
         <p:spPr>
           <a:xfrm>
-            <a:off x="9052560" y="1554480"/>
-            <a:ext cx="914400" cy="1975104"/>
+            <a:off x="9390888" y="2377440"/>
+            <a:ext cx="914400" cy="2148840"/>
+          </a:xfrm>
+          <a:prstGeom prst="roundRect">
+            <a:avLst>
+              <a:gd name="adj" fmla="val 10000"/>
+            </a:avLst>
+          </a:prstGeom>
+          <a:ln w="19050">
+            <a:solidFill>
+              <a:srgbClr val="4FC3F7"/>
+            </a:solidFill>
+            <a:prstDash val="solid"/>
+          </a:ln>
+        </p:spPr>
+      </p:sp>
+      <p:sp>
+        <p:nvSpPr>
+          <p:cNvPr id="61" name="Shape 47"/>
+          <p:cNvSpPr/>
+          <p:nvPr/>
+        </p:nvSpPr>
+        <p:spPr>
+          <a:xfrm>
+            <a:off x="9985248" y="1810512"/>
+            <a:ext cx="27432" cy="530352"/>
           </a:xfrm>
           <a:custGeom>
             <a:avLst/>
@@ -2865,15 +2939,13 @@
             <a:cxnLst/>
             <a:rect l="l" t="t" r="r" b="b"/>
             <a:pathLst>
-              <a:path w="914400" h="1975104">
+              <a:path w="27432" h="530352">
                 <a:moveTo>
-                  <a:pt x="0" y="1975104"/>
+                  <a:pt x="0" y="530352"/>
                 </a:moveTo>
-                <a:cubicBezTo>
-                  <a:pt x="45720" y="1188720"/>
-                  <a:pt x="411480" y="274320"/>
-                  <a:pt x="914400" y="0"/>
-                </a:cubicBezTo>
+                <a:lnTo>
+                  <a:pt x="27432" y="0"/>
+                </a:lnTo>
               </a:path>
             </a:pathLst>
           </a:custGeom>
@@ -2889,14 +2961,14 @@
       </p:sp>
       <p:sp>
         <p:nvSpPr>
-          <p:cNvPr id="59" name="caption-arrow"/>
+          <p:cNvPr id="62" name="caption-arrow"/>
           <p:cNvSpPr txBox="1"/>
           <p:nvPr/>
         </p:nvSpPr>
         <p:spPr>
           <a:xfrm>
-            <a:off x="8138160" y="1874520"/>
-            <a:ext cx="1143000" cy="274320"/>
+            <a:off x="8366760" y="1947672"/>
+            <a:ext cx="1280160" cy="274320"/>
           </a:xfrm>
           <a:prstGeom prst="rect">
             <a:avLst/>
@@ -2928,7 +3000,7 @@
       </p:sp>
       <p:sp>
         <p:nvSpPr>
-          <p:cNvPr id="60" name="Shape 48"/>
+          <p:cNvPr id="63" name="Shape 49"/>
           <p:cNvSpPr/>
           <p:nvPr/>
         </p:nvSpPr>
@@ -2968,7 +3040,7 @@
       </p:sp>
       <p:sp>
         <p:nvSpPr>
-          <p:cNvPr id="61" name="caption-arrow"/>
+          <p:cNvPr id="64" name="caption-arrow"/>
           <p:cNvSpPr txBox="1"/>
           <p:nvPr/>
         </p:nvSpPr>
@@ -3007,7 +3079,7 @@
       </p:sp>
       <p:sp>
         <p:nvSpPr>
-          <p:cNvPr id="62" name="Shape 50"/>
+          <p:cNvPr id="65" name="Shape 51"/>
           <p:cNvSpPr/>
           <p:nvPr/>
         </p:nvSpPr>
@@ -3045,7 +3117,7 @@
       </p:sp>
       <p:sp>
         <p:nvSpPr>
-          <p:cNvPr id="63" name="caption-arrow"/>
+          <p:cNvPr id="66" name="caption-arrow"/>
           <p:cNvSpPr txBox="1"/>
           <p:nvPr/>
         </p:nvSpPr>
@@ -3084,14 +3156,14 @@
       </p:sp>
       <p:pic>
         <p:nvPicPr>
-          <p:cNvPr id="64" name="Image 10" descr="preencoded.png">    </p:cNvPr>
+          <p:cNvPr id="67" name="Image 12" descr="preencoded.png">    </p:cNvPr>
           <p:cNvPicPr>
             <a:picLocks noChangeAspect="1"/>
           </p:cNvPicPr>
           <p:nvPr/>
         </p:nvPicPr>
         <p:blipFill>
-          <a:blip r:embed="rId12"/>
+          <a:blip r:embed="rId14"/>
           <a:stretch>
             <a:fillRect/>
           </a:stretch>
@@ -3108,7 +3180,7 @@
       </p:pic>
       <p:sp>
         <p:nvSpPr>
-          <p:cNvPr id="65" name="label"/>
+          <p:cNvPr id="68" name="label"/>
           <p:cNvSpPr txBox="1"/>
           <p:nvPr/>
         </p:nvSpPr>
@@ -3147,7 +3219,7 @@
       </p:sp>
       <p:sp>
         <p:nvSpPr>
-          <p:cNvPr id="66" name="Shape 53"/>
+          <p:cNvPr id="69" name="Shape 54"/>
           <p:cNvSpPr/>
           <p:nvPr/>
         </p:nvSpPr>
@@ -3172,7 +3244,7 @@
       </p:sp>
       <p:sp>
         <p:nvSpPr>
-          <p:cNvPr id="67" name="caption-badge"/>
+          <p:cNvPr id="70" name="caption-badge"/>
           <p:cNvSpPr txBox="1"/>
           <p:nvPr/>
         </p:nvSpPr>
@@ -3211,14 +3283,14 @@
       </p:sp>
       <p:sp>
         <p:nvSpPr>
-          <p:cNvPr id="68" name="Shape 55"/>
+          <p:cNvPr id="71" name="Shape 56"/>
           <p:cNvSpPr/>
           <p:nvPr/>
         </p:nvSpPr>
         <p:spPr>
           <a:xfrm>
             <a:off x="5760720" y="5486400"/>
-            <a:ext cx="2377440" cy="1097280"/>
+            <a:ext cx="2788920" cy="1097280"/>
           </a:xfrm>
           <a:prstGeom prst="roundRect">
             <a:avLst>
@@ -3240,22 +3312,22 @@
       </p:sp>
       <p:pic>
         <p:nvPicPr>
-          <p:cNvPr id="69" name="Image 11" descr="preencoded.png">    </p:cNvPr>
+          <p:cNvPr id="72" name="Image 13" descr="preencoded.png">    </p:cNvPr>
           <p:cNvPicPr>
             <a:picLocks noChangeAspect="1"/>
           </p:cNvPicPr>
           <p:nvPr/>
         </p:nvPicPr>
         <p:blipFill>
-          <a:blip r:embed="rId13"/>
+          <a:blip r:embed="rId15"/>
           <a:stretch>
             <a:fillRect/>
           </a:stretch>
         </p:blipFill>
         <p:spPr>
           <a:xfrm>
-            <a:off x="5897880" y="5788152"/>
-            <a:ext cx="475488" cy="475488"/>
+            <a:off x="5852160" y="5577840"/>
+            <a:ext cx="841248" cy="914400"/>
           </a:xfrm>
           <a:prstGeom prst="rect">
             <a:avLst/>
@@ -3264,14 +3336,14 @@
       </p:pic>
       <p:sp>
         <p:nvSpPr>
-          <p:cNvPr id="70" name="label"/>
+          <p:cNvPr id="73" name="label"/>
           <p:cNvSpPr txBox="1"/>
           <p:nvPr/>
         </p:nvSpPr>
         <p:spPr>
           <a:xfrm>
-            <a:off x="6446520" y="5596128"/>
-            <a:ext cx="1645920" cy="384048"/>
+            <a:off x="6784848" y="5596128"/>
+            <a:ext cx="1691640" cy="384048"/>
           </a:xfrm>
           <a:prstGeom prst="rect">
             <a:avLst/>
@@ -3303,14 +3375,14 @@
       </p:sp>
       <p:sp>
         <p:nvSpPr>
-          <p:cNvPr id="71" name="caption-sub"/>
+          <p:cNvPr id="74" name="caption-sub"/>
           <p:cNvSpPr txBox="1"/>
           <p:nvPr/>
         </p:nvSpPr>
         <p:spPr>
           <a:xfrm>
-            <a:off x="6446520" y="6016752"/>
-            <a:ext cx="1645920" cy="457200"/>
+            <a:off x="6784848" y="6016752"/>
+            <a:ext cx="1691640" cy="457200"/>
           </a:xfrm>
           <a:prstGeom prst="rect">
             <a:avLst/>
@@ -3342,7 +3414,7 @@
       </p:sp>
       <p:sp>
         <p:nvSpPr>
-          <p:cNvPr id="72" name="Shape 58"/>
+          <p:cNvPr id="75" name="Shape 59"/>
           <p:cNvSpPr/>
           <p:nvPr/>
         </p:nvSpPr>
@@ -3367,7 +3439,7 @@
       </p:sp>
       <p:sp>
         <p:nvSpPr>
-          <p:cNvPr id="73" name="caption-badge"/>
+          <p:cNvPr id="76" name="caption-badge"/>
           <p:cNvSpPr txBox="1"/>
           <p:nvPr/>
         </p:nvSpPr>
@@ -3406,14 +3478,14 @@
       </p:sp>
       <p:sp>
         <p:nvSpPr>
-          <p:cNvPr id="74" name="Shape 60"/>
+          <p:cNvPr id="77" name="Shape 61"/>
           <p:cNvSpPr/>
           <p:nvPr/>
         </p:nvSpPr>
         <p:spPr>
           <a:xfrm>
-            <a:off x="8174736" y="6053328"/>
-            <a:ext cx="374904" cy="18288"/>
+            <a:off x="8586216" y="6053328"/>
+            <a:ext cx="786384" cy="18288"/>
           </a:xfrm>
           <a:custGeom>
             <a:avLst/>
@@ -3422,9 +3494,9 @@
             <a:cxnLst/>
             <a:rect l="l" t="t" r="r" b="b"/>
             <a:pathLst>
-              <a:path w="374904" h="18288">
+              <a:path w="786384" h="18288">
                 <a:moveTo>
-                  <a:pt x="374904" y="0"/>
+                  <a:pt x="786384" y="0"/>
                 </a:moveTo>
                 <a:lnTo>
                   <a:pt x="0" y="0"/>
@@ -3444,14 +3516,14 @@
       </p:sp>
       <p:sp>
         <p:nvSpPr>
-          <p:cNvPr id="75" name="caption-arrow"/>
+          <p:cNvPr id="78" name="caption-arrow"/>
           <p:cNvSpPr txBox="1"/>
           <p:nvPr/>
         </p:nvSpPr>
         <p:spPr>
           <a:xfrm>
-            <a:off x="8229600" y="6382512"/>
-            <a:ext cx="1188720" cy="274320"/>
+            <a:off x="8595360" y="6382512"/>
+            <a:ext cx="777240" cy="274320"/>
           </a:xfrm>
           <a:prstGeom prst="rect">
             <a:avLst/>
@@ -3483,7 +3555,7 @@
       </p:sp>
       <p:sp>
         <p:nvSpPr>
-          <p:cNvPr id="76" name="Shape 62"/>
+          <p:cNvPr id="79" name="Shape 63"/>
           <p:cNvSpPr/>
           <p:nvPr/>
         </p:nvSpPr>
@@ -3521,7 +3593,7 @@
       </p:sp>
       <p:sp>
         <p:nvSpPr>
-          <p:cNvPr id="77" name="caption-arrow"/>
+          <p:cNvPr id="80" name="caption-arrow"/>
           <p:cNvSpPr txBox="1"/>
           <p:nvPr/>
         </p:nvSpPr>
@@ -3560,7 +3632,7 @@
       </p:sp>
       <p:sp>
         <p:nvSpPr>
-          <p:cNvPr id="78" name="Shape 64"/>
+          <p:cNvPr id="81" name="Shape 65"/>
           <p:cNvSpPr/>
           <p:nvPr/>
         </p:nvSpPr>
@@ -3601,7 +3673,7 @@
       </p:sp>
       <p:sp>
         <p:nvSpPr>
-          <p:cNvPr id="79" name="caption-arrow"/>
+          <p:cNvPr id="82" name="caption-arrow"/>
           <p:cNvSpPr txBox="1"/>
           <p:nvPr/>
         </p:nvSpPr>
@@ -3640,14 +3712,14 @@
       </p:sp>
       <p:pic>
         <p:nvPicPr>
-          <p:cNvPr id="80" name="Image 12" descr="preencoded.png">    </p:cNvPr>
+          <p:cNvPr id="83" name="Image 14" descr="preencoded.png">    </p:cNvPr>
           <p:cNvPicPr>
             <a:picLocks noChangeAspect="1"/>
           </p:cNvPicPr>
           <p:nvPr/>
         </p:nvPicPr>
         <p:blipFill>
-          <a:blip r:embed="rId14"/>
+          <a:blip r:embed="rId16"/>
           <a:stretch>
             <a:fillRect/>
           </a:stretch>
@@ -3664,7 +3736,7 @@
       </p:pic>
       <p:sp>
         <p:nvSpPr>
-          <p:cNvPr id="81" name="Shape 66"/>
+          <p:cNvPr id="84" name="Shape 67"/>
           <p:cNvSpPr/>
           <p:nvPr/>
         </p:nvSpPr>
@@ -3688,7 +3760,7 @@
       </p:sp>
       <p:sp>
         <p:nvSpPr>
-          <p:cNvPr id="82" name="caption-legend"/>
+          <p:cNvPr id="85" name="caption-legend"/>
           <p:cNvSpPr txBox="1"/>
           <p:nvPr/>
         </p:nvSpPr>
@@ -3727,7 +3799,7 @@
       </p:sp>
       <p:sp>
         <p:nvSpPr>
-          <p:cNvPr id="83" name="Shape 68"/>
+          <p:cNvPr id="86" name="Shape 69"/>
           <p:cNvSpPr/>
           <p:nvPr/>
         </p:nvSpPr>
@@ -3751,7 +3823,7 @@
       </p:sp>
       <p:sp>
         <p:nvSpPr>
-          <p:cNvPr id="84" name="caption-legend"/>
+          <p:cNvPr id="87" name="caption-legend"/>
           <p:cNvSpPr txBox="1"/>
           <p:nvPr/>
         </p:nvSpPr>
@@ -3790,7 +3862,7 @@
       </p:sp>
       <p:sp>
         <p:nvSpPr>
-          <p:cNvPr id="85" name="Shape 70"/>
+          <p:cNvPr id="88" name="Shape 71"/>
           <p:cNvSpPr/>
           <p:nvPr/>
         </p:nvSpPr>
@@ -3814,7 +3886,7 @@
       </p:sp>
       <p:sp>
         <p:nvSpPr>
-          <p:cNvPr id="86" name="caption-legend"/>
+          <p:cNvPr id="89" name="caption-legend"/>
           <p:cNvSpPr txBox="1"/>
           <p:nvPr/>
         </p:nvSpPr>
@@ -3853,7 +3925,7 @@
       </p:sp>
       <p:sp>
         <p:nvSpPr>
-          <p:cNvPr id="87" name="Shape 72"/>
+          <p:cNvPr id="90" name="Shape 73"/>
           <p:cNvSpPr/>
           <p:nvPr/>
         </p:nvSpPr>
@@ -3877,7 +3949,7 @@
       </p:sp>
       <p:sp>
         <p:nvSpPr>
-          <p:cNvPr id="88" name="caption-legend"/>
+          <p:cNvPr id="91" name="caption-legend"/>
           <p:cNvSpPr txBox="1"/>
           <p:nvPr/>
         </p:nvSpPr>

</xml_diff>

<commit_message>
Remove the cooling-tower photo from the diagram slide
The vapor arrow goes from the Cooling tower card to the clouds again, and
the notes no longer mention the photo.

Co-Authored-By: Claude Opus 5.5 <noreply@anthropic.com>
Claude-Session: https://claude.ai/code/session_01D1yfgr7znJrRSehnJ7HGe8
</commit_message>
<xml_diff>
--- a/ai-diagram-slide.pptx
+++ b/ai-diagram-slide.pptx
@@ -568,13 +568,7 @@
           <a:p>
             <a:r>
               <a:rPr lang="en-US" dirty="0"/>
-              <a:t>About the cooling-tower photo: big round towers like this one are mostly at power plants. Data-center cooling towers are smaller boxes, but they work the same way: water evaporates and carries the heat away.</a:t>
-            </a:r>
-          </a:p>
-          <a:p>
-            <a:r>
-              <a:rPr lang="en-US" dirty="0"/>
-              <a:t>Photos: our team's pictures of a phone, server racks (behind the data center), a cooling tower and a desalination plant.</a:t>
+              <a:t>Photos: our team's pictures of a phone, server racks (behind the data center) and a desalination plant.</a:t>
             </a:r>
           </a:p>
         </p:txBody>
@@ -2873,64 +2867,16 @@
           </a:p>
         </p:txBody>
       </p:sp>
-      <p:pic>
-        <p:nvPicPr>
-          <p:cNvPr id="59" name="Image 11" descr="preencoded.png">    </p:cNvPr>
-          <p:cNvPicPr>
-            <a:picLocks noChangeAspect="1"/>
-          </p:cNvPicPr>
-          <p:nvPr/>
-        </p:nvPicPr>
-        <p:blipFill>
-          <a:blip r:embed="rId13"/>
-          <a:stretch>
-            <a:fillRect/>
-          </a:stretch>
-        </p:blipFill>
-        <p:spPr>
-          <a:xfrm>
-            <a:off x="9390888" y="2377440"/>
-            <a:ext cx="914400" cy="2148840"/>
-          </a:xfrm>
-          <a:prstGeom prst="rect">
-            <a:avLst/>
-          </a:prstGeom>
-        </p:spPr>
-      </p:pic>
-      <p:sp>
-        <p:nvSpPr>
-          <p:cNvPr id="60" name="Shape 46"/>
+      <p:sp>
+        <p:nvSpPr>
+          <p:cNvPr id="59" name="Shape 46"/>
           <p:cNvSpPr/>
           <p:nvPr/>
         </p:nvSpPr>
         <p:spPr>
           <a:xfrm>
-            <a:off x="9390888" y="2377440"/>
-            <a:ext cx="914400" cy="2148840"/>
-          </a:xfrm>
-          <a:prstGeom prst="roundRect">
-            <a:avLst>
-              <a:gd name="adj" fmla="val 10000"/>
-            </a:avLst>
-          </a:prstGeom>
-          <a:ln w="19050">
-            <a:solidFill>
-              <a:srgbClr val="4FC3F7"/>
-            </a:solidFill>
-            <a:prstDash val="solid"/>
-          </a:ln>
-        </p:spPr>
-      </p:sp>
-      <p:sp>
-        <p:nvSpPr>
-          <p:cNvPr id="61" name="Shape 47"/>
-          <p:cNvSpPr/>
-          <p:nvPr/>
-        </p:nvSpPr>
-        <p:spPr>
-          <a:xfrm>
-            <a:off x="9985248" y="1810512"/>
-            <a:ext cx="27432" cy="530352"/>
+            <a:off x="9052560" y="1554480"/>
+            <a:ext cx="914400" cy="1975104"/>
           </a:xfrm>
           <a:custGeom>
             <a:avLst/>
@@ -2939,13 +2885,15 @@
             <a:cxnLst/>
             <a:rect l="l" t="t" r="r" b="b"/>
             <a:pathLst>
-              <a:path w="27432" h="530352">
+              <a:path w="914400" h="1975104">
                 <a:moveTo>
-                  <a:pt x="0" y="530352"/>
+                  <a:pt x="0" y="1975104"/>
                 </a:moveTo>
-                <a:lnTo>
-                  <a:pt x="27432" y="0"/>
-                </a:lnTo>
+                <a:cubicBezTo>
+                  <a:pt x="45720" y="1188720"/>
+                  <a:pt x="411480" y="274320"/>
+                  <a:pt x="914400" y="0"/>
+                </a:cubicBezTo>
               </a:path>
             </a:pathLst>
           </a:custGeom>
@@ -2961,14 +2909,14 @@
       </p:sp>
       <p:sp>
         <p:nvSpPr>
-          <p:cNvPr id="62" name="caption-arrow"/>
+          <p:cNvPr id="60" name="caption-arrow"/>
           <p:cNvSpPr txBox="1"/>
           <p:nvPr/>
         </p:nvSpPr>
         <p:spPr>
           <a:xfrm>
-            <a:off x="8366760" y="1947672"/>
-            <a:ext cx="1280160" cy="274320"/>
+            <a:off x="8138160" y="1874520"/>
+            <a:ext cx="1143000" cy="274320"/>
           </a:xfrm>
           <a:prstGeom prst="rect">
             <a:avLst/>
@@ -3000,7 +2948,7 @@
       </p:sp>
       <p:sp>
         <p:nvSpPr>
-          <p:cNvPr id="63" name="Shape 49"/>
+          <p:cNvPr id="61" name="Shape 48"/>
           <p:cNvSpPr/>
           <p:nvPr/>
         </p:nvSpPr>
@@ -3040,7 +2988,7 @@
       </p:sp>
       <p:sp>
         <p:nvSpPr>
-          <p:cNvPr id="64" name="caption-arrow"/>
+          <p:cNvPr id="62" name="caption-arrow"/>
           <p:cNvSpPr txBox="1"/>
           <p:nvPr/>
         </p:nvSpPr>
@@ -3079,7 +3027,7 @@
       </p:sp>
       <p:sp>
         <p:nvSpPr>
-          <p:cNvPr id="65" name="Shape 51"/>
+          <p:cNvPr id="63" name="Shape 50"/>
           <p:cNvSpPr/>
           <p:nvPr/>
         </p:nvSpPr>
@@ -3117,7 +3065,7 @@
       </p:sp>
       <p:sp>
         <p:nvSpPr>
-          <p:cNvPr id="66" name="caption-arrow"/>
+          <p:cNvPr id="64" name="caption-arrow"/>
           <p:cNvSpPr txBox="1"/>
           <p:nvPr/>
         </p:nvSpPr>
@@ -3156,14 +3104,14 @@
       </p:sp>
       <p:pic>
         <p:nvPicPr>
-          <p:cNvPr id="67" name="Image 12" descr="preencoded.png">    </p:cNvPr>
+          <p:cNvPr id="65" name="Image 11" descr="preencoded.png">    </p:cNvPr>
           <p:cNvPicPr>
             <a:picLocks noChangeAspect="1"/>
           </p:cNvPicPr>
           <p:nvPr/>
         </p:nvPicPr>
         <p:blipFill>
-          <a:blip r:embed="rId14"/>
+          <a:blip r:embed="rId13"/>
           <a:stretch>
             <a:fillRect/>
           </a:stretch>
@@ -3180,7 +3128,7 @@
       </p:pic>
       <p:sp>
         <p:nvSpPr>
-          <p:cNvPr id="68" name="label"/>
+          <p:cNvPr id="66" name="label"/>
           <p:cNvSpPr txBox="1"/>
           <p:nvPr/>
         </p:nvSpPr>
@@ -3219,7 +3167,7 @@
       </p:sp>
       <p:sp>
         <p:nvSpPr>
-          <p:cNvPr id="69" name="Shape 54"/>
+          <p:cNvPr id="67" name="Shape 53"/>
           <p:cNvSpPr/>
           <p:nvPr/>
         </p:nvSpPr>
@@ -3244,7 +3192,7 @@
       </p:sp>
       <p:sp>
         <p:nvSpPr>
-          <p:cNvPr id="70" name="caption-badge"/>
+          <p:cNvPr id="68" name="caption-badge"/>
           <p:cNvSpPr txBox="1"/>
           <p:nvPr/>
         </p:nvSpPr>
@@ -3283,7 +3231,7 @@
       </p:sp>
       <p:sp>
         <p:nvSpPr>
-          <p:cNvPr id="71" name="Shape 56"/>
+          <p:cNvPr id="69" name="Shape 55"/>
           <p:cNvSpPr/>
           <p:nvPr/>
         </p:nvSpPr>
@@ -3312,14 +3260,14 @@
       </p:sp>
       <p:pic>
         <p:nvPicPr>
-          <p:cNvPr id="72" name="Image 13" descr="preencoded.png">    </p:cNvPr>
+          <p:cNvPr id="70" name="Image 12" descr="preencoded.png">    </p:cNvPr>
           <p:cNvPicPr>
             <a:picLocks noChangeAspect="1"/>
           </p:cNvPicPr>
           <p:nvPr/>
         </p:nvPicPr>
         <p:blipFill>
-          <a:blip r:embed="rId15"/>
+          <a:blip r:embed="rId14"/>
           <a:stretch>
             <a:fillRect/>
           </a:stretch>
@@ -3336,7 +3284,7 @@
       </p:pic>
       <p:sp>
         <p:nvSpPr>
-          <p:cNvPr id="73" name="label"/>
+          <p:cNvPr id="71" name="label"/>
           <p:cNvSpPr txBox="1"/>
           <p:nvPr/>
         </p:nvSpPr>
@@ -3375,7 +3323,7 @@
       </p:sp>
       <p:sp>
         <p:nvSpPr>
-          <p:cNvPr id="74" name="caption-sub"/>
+          <p:cNvPr id="72" name="caption-sub"/>
           <p:cNvSpPr txBox="1"/>
           <p:nvPr/>
         </p:nvSpPr>
@@ -3414,7 +3362,7 @@
       </p:sp>
       <p:sp>
         <p:nvSpPr>
-          <p:cNvPr id="75" name="Shape 59"/>
+          <p:cNvPr id="73" name="Shape 58"/>
           <p:cNvSpPr/>
           <p:nvPr/>
         </p:nvSpPr>
@@ -3439,7 +3387,7 @@
       </p:sp>
       <p:sp>
         <p:nvSpPr>
-          <p:cNvPr id="76" name="caption-badge"/>
+          <p:cNvPr id="74" name="caption-badge"/>
           <p:cNvSpPr txBox="1"/>
           <p:nvPr/>
         </p:nvSpPr>
@@ -3478,7 +3426,7 @@
       </p:sp>
       <p:sp>
         <p:nvSpPr>
-          <p:cNvPr id="77" name="Shape 61"/>
+          <p:cNvPr id="75" name="Shape 60"/>
           <p:cNvSpPr/>
           <p:nvPr/>
         </p:nvSpPr>
@@ -3516,7 +3464,7 @@
       </p:sp>
       <p:sp>
         <p:nvSpPr>
-          <p:cNvPr id="78" name="caption-arrow"/>
+          <p:cNvPr id="76" name="caption-arrow"/>
           <p:cNvSpPr txBox="1"/>
           <p:nvPr/>
         </p:nvSpPr>
@@ -3555,7 +3503,7 @@
       </p:sp>
       <p:sp>
         <p:nvSpPr>
-          <p:cNvPr id="79" name="Shape 63"/>
+          <p:cNvPr id="77" name="Shape 62"/>
           <p:cNvSpPr/>
           <p:nvPr/>
         </p:nvSpPr>
@@ -3593,7 +3541,7 @@
       </p:sp>
       <p:sp>
         <p:nvSpPr>
-          <p:cNvPr id="80" name="caption-arrow"/>
+          <p:cNvPr id="78" name="caption-arrow"/>
           <p:cNvSpPr txBox="1"/>
           <p:nvPr/>
         </p:nvSpPr>
@@ -3632,7 +3580,7 @@
       </p:sp>
       <p:sp>
         <p:nvSpPr>
-          <p:cNvPr id="81" name="Shape 65"/>
+          <p:cNvPr id="79" name="Shape 64"/>
           <p:cNvSpPr/>
           <p:nvPr/>
         </p:nvSpPr>
@@ -3673,7 +3621,7 @@
       </p:sp>
       <p:sp>
         <p:nvSpPr>
-          <p:cNvPr id="82" name="caption-arrow"/>
+          <p:cNvPr id="80" name="caption-arrow"/>
           <p:cNvSpPr txBox="1"/>
           <p:nvPr/>
         </p:nvSpPr>
@@ -3712,14 +3660,14 @@
       </p:sp>
       <p:pic>
         <p:nvPicPr>
-          <p:cNvPr id="83" name="Image 14" descr="preencoded.png">    </p:cNvPr>
+          <p:cNvPr id="81" name="Image 13" descr="preencoded.png">    </p:cNvPr>
           <p:cNvPicPr>
             <a:picLocks noChangeAspect="1"/>
           </p:cNvPicPr>
           <p:nvPr/>
         </p:nvPicPr>
         <p:blipFill>
-          <a:blip r:embed="rId16"/>
+          <a:blip r:embed="rId15"/>
           <a:stretch>
             <a:fillRect/>
           </a:stretch>
@@ -3736,7 +3684,7 @@
       </p:pic>
       <p:sp>
         <p:nvSpPr>
-          <p:cNvPr id="84" name="Shape 67"/>
+          <p:cNvPr id="82" name="Shape 66"/>
           <p:cNvSpPr/>
           <p:nvPr/>
         </p:nvSpPr>
@@ -3760,7 +3708,7 @@
       </p:sp>
       <p:sp>
         <p:nvSpPr>
-          <p:cNvPr id="85" name="caption-legend"/>
+          <p:cNvPr id="83" name="caption-legend"/>
           <p:cNvSpPr txBox="1"/>
           <p:nvPr/>
         </p:nvSpPr>
@@ -3799,7 +3747,7 @@
       </p:sp>
       <p:sp>
         <p:nvSpPr>
-          <p:cNvPr id="86" name="Shape 69"/>
+          <p:cNvPr id="84" name="Shape 68"/>
           <p:cNvSpPr/>
           <p:nvPr/>
         </p:nvSpPr>
@@ -3823,7 +3771,7 @@
       </p:sp>
       <p:sp>
         <p:nvSpPr>
-          <p:cNvPr id="87" name="caption-legend"/>
+          <p:cNvPr id="85" name="caption-legend"/>
           <p:cNvSpPr txBox="1"/>
           <p:nvPr/>
         </p:nvSpPr>
@@ -3862,7 +3810,7 @@
       </p:sp>
       <p:sp>
         <p:nvSpPr>
-          <p:cNvPr id="88" name="Shape 71"/>
+          <p:cNvPr id="86" name="Shape 70"/>
           <p:cNvSpPr/>
           <p:nvPr/>
         </p:nvSpPr>
@@ -3886,7 +3834,7 @@
       </p:sp>
       <p:sp>
         <p:nvSpPr>
-          <p:cNvPr id="89" name="caption-legend"/>
+          <p:cNvPr id="87" name="caption-legend"/>
           <p:cNvSpPr txBox="1"/>
           <p:nvPr/>
         </p:nvSpPr>
@@ -3925,7 +3873,7 @@
       </p:sp>
       <p:sp>
         <p:nvSpPr>
-          <p:cNvPr id="90" name="Shape 73"/>
+          <p:cNvPr id="88" name="Shape 72"/>
           <p:cNvSpPr/>
           <p:nvPr/>
         </p:nvSpPr>
@@ -3949,7 +3897,7 @@
       </p:sp>
       <p:sp>
         <p:nvSpPr>
-          <p:cNvPr id="91" name="caption-legend"/>
+          <p:cNvPr id="89" name="caption-legend"/>
           <p:cNvSpPr txBox="1"/>
           <p:nvPr/>
         </p:nvSpPr>

</xml_diff>

<commit_message>
Add dam and wind-turbine photos to the diagram slide
The River & dam card shows the team's dam photo and the Power plant card
the wind-turbine photo, with stronger fades and soft label shadows so the
text stays readable. The power plant line now reads "Wind, falling water
or steam spins a turbine" to match the picture; the notes add that wind
turbines use almost no water.

Co-Authored-By: Claude Opus 5.5 <noreply@anthropic.com>
Claude-Session: https://claude.ai/code/session_01D1yfgr7znJrRSehnJ7HGe8
</commit_message>
<xml_diff>
--- a/ai-diagram-slide.pptx
+++ b/ai-diagram-slide.pptx
@@ -568,7 +568,13 @@
           <a:p>
             <a:r>
               <a:rPr lang="en-US" dirty="0"/>
-              <a:t>Photos: our team's pictures of a phone, server racks (behind the data center) and a desalination plant.</a:t>
+              <a:t>Photos: our team's pictures of a dam, wind turbines (power plant), a phone, server racks (behind the data center) and a desalination plant.</a:t>
+            </a:r>
+          </a:p>
+          <a:p>
+            <a:r>
+              <a:rPr lang="en-US" dirty="0"/>
+              <a:t>Wind turbines are spun by wind, not water, and use almost no water to make electricity. That is one way to make AI's power less thirsty.</a:t>
             </a:r>
           </a:p>
         </p:txBody>
@@ -2032,38 +2038,9 @@
           </a:p>
         </p:txBody>
       </p:sp>
-      <p:sp>
-        <p:nvSpPr>
-          <p:cNvPr id="34" name="Shape 26"/>
-          <p:cNvSpPr/>
-          <p:nvPr/>
-        </p:nvSpPr>
-        <p:spPr>
-          <a:xfrm>
-            <a:off x="320040" y="1097280"/>
-            <a:ext cx="1828800" cy="1234440"/>
-          </a:xfrm>
-          <a:prstGeom prst="roundRect">
-            <a:avLst>
-              <a:gd name="adj" fmla="val 8889"/>
-            </a:avLst>
-          </a:prstGeom>
-          <a:solidFill>
-            <a:srgbClr val="0E1B2A">
-              <a:alpha val="90000"/>
-            </a:srgbClr>
-          </a:solidFill>
-          <a:ln w="19050">
-            <a:solidFill>
-              <a:srgbClr val="4FC3F7"/>
-            </a:solidFill>
-            <a:prstDash val="solid"/>
-          </a:ln>
-        </p:spPr>
-      </p:sp>
       <p:pic>
         <p:nvPicPr>
-          <p:cNvPr id="35" name="Image 6" descr="preencoded.png">    </p:cNvPr>
+          <p:cNvPr id="34" name="Image 6" descr="preencoded.png">    </p:cNvPr>
           <p:cNvPicPr>
             <a:picLocks noChangeAspect="1"/>
           </p:cNvPicPr>
@@ -2077,14 +2054,38 @@
         </p:blipFill>
         <p:spPr>
           <a:xfrm>
-            <a:off x="1024128" y="1188720"/>
-            <a:ext cx="420624" cy="420624"/>
+            <a:off x="320040" y="1097280"/>
+            <a:ext cx="1828800" cy="1234440"/>
           </a:xfrm>
           <a:prstGeom prst="rect">
             <a:avLst/>
           </a:prstGeom>
         </p:spPr>
       </p:pic>
+      <p:sp>
+        <p:nvSpPr>
+          <p:cNvPr id="35" name="Shape 26"/>
+          <p:cNvSpPr/>
+          <p:nvPr/>
+        </p:nvSpPr>
+        <p:spPr>
+          <a:xfrm>
+            <a:off x="320040" y="1097280"/>
+            <a:ext cx="1828800" cy="1234440"/>
+          </a:xfrm>
+          <a:prstGeom prst="roundRect">
+            <a:avLst>
+              <a:gd name="adj" fmla="val 8889"/>
+            </a:avLst>
+          </a:prstGeom>
+          <a:ln w="19050">
+            <a:solidFill>
+              <a:srgbClr val="4FC3F7"/>
+            </a:solidFill>
+            <a:prstDash val="solid"/>
+          </a:ln>
+        </p:spPr>
+      </p:sp>
       <p:sp>
         <p:nvSpPr>
           <p:cNvPr id="36" name="label"/>
@@ -2093,7 +2094,7 @@
         </p:nvSpPr>
         <p:spPr>
           <a:xfrm>
-            <a:off x="320040" y="1627632"/>
+            <a:off x="320040" y="1581912"/>
             <a:ext cx="1828800" cy="329184"/>
           </a:xfrm>
           <a:prstGeom prst="rect">
@@ -2101,6 +2102,13 @@
           </a:prstGeom>
           <a:noFill/>
           <a:ln/>
+          <a:effectLst>
+            <a:outerShdw sx="100000" sy="100000" kx="0" ky="0" algn="bl" rotWithShape="0" blurRad="76200" dist="19050" dir="5400000">
+              <a:srgbClr val="000000">
+                <a:alpha val="70000"/>
+              </a:srgbClr>
+            </a:outerShdw>
+          </a:effectLst>
         </p:spPr>
         <p:txBody>
           <a:bodyPr wrap="square" lIns="0" tIns="0" rIns="0" bIns="0" rtlCol="0" anchor="ctr"/>
@@ -2132,17 +2140,24 @@
         </p:nvSpPr>
         <p:spPr>
           <a:xfrm>
-            <a:off x="393192" y="1965960"/>
-            <a:ext cx="1682496" cy="320040"/>
+            <a:off x="393192" y="1901952"/>
+            <a:ext cx="1682496" cy="402336"/>
           </a:xfrm>
           <a:prstGeom prst="rect">
             <a:avLst/>
           </a:prstGeom>
           <a:noFill/>
           <a:ln/>
-        </p:spPr>
-        <p:txBody>
-          <a:bodyPr wrap="square" lIns="0" tIns="0" rIns="0" bIns="0" rtlCol="0" anchor="t"/>
+          <a:effectLst>
+            <a:outerShdw sx="100000" sy="100000" kx="0" ky="0" algn="bl" rotWithShape="0" blurRad="76200" dist="19050" dir="5400000">
+              <a:srgbClr val="000000">
+                <a:alpha val="70000"/>
+              </a:srgbClr>
+            </a:outerShdw>
+          </a:effectLst>
+        </p:spPr>
+        <p:txBody>
+          <a:bodyPr wrap="square" lIns="0" tIns="0" rIns="0" bIns="0" rtlCol="0" anchor="ctr"/>
           <a:lstStyle/>
           <a:p>
             <a:pPr algn="ctr" indent="0" marL="0">
@@ -2163,38 +2178,9 @@
           </a:p>
         </p:txBody>
       </p:sp>
-      <p:sp>
-        <p:nvSpPr>
-          <p:cNvPr id="38" name="Shape 29"/>
-          <p:cNvSpPr/>
-          <p:nvPr/>
-        </p:nvSpPr>
-        <p:spPr>
-          <a:xfrm>
-            <a:off x="320040" y="3291840"/>
-            <a:ext cx="1828800" cy="1353312"/>
-          </a:xfrm>
-          <a:prstGeom prst="roundRect">
-            <a:avLst>
-              <a:gd name="adj" fmla="val 8108"/>
-            </a:avLst>
-          </a:prstGeom>
-          <a:solidFill>
-            <a:srgbClr val="0E1B2A">
-              <a:alpha val="90000"/>
-            </a:srgbClr>
-          </a:solidFill>
-          <a:ln w="19050">
-            <a:solidFill>
-              <a:srgbClr val="F2A33A"/>
-            </a:solidFill>
-            <a:prstDash val="solid"/>
-          </a:ln>
-        </p:spPr>
-      </p:sp>
       <p:pic>
         <p:nvPicPr>
-          <p:cNvPr id="39" name="Image 7" descr="preencoded.png">    </p:cNvPr>
+          <p:cNvPr id="38" name="Image 7" descr="preencoded.png">    </p:cNvPr>
           <p:cNvPicPr>
             <a:picLocks noChangeAspect="1"/>
           </p:cNvPicPr>
@@ -2208,14 +2194,38 @@
         </p:blipFill>
         <p:spPr>
           <a:xfrm>
-            <a:off x="1024128" y="3383280"/>
-            <a:ext cx="420624" cy="420624"/>
+            <a:off x="320040" y="3291840"/>
+            <a:ext cx="1828800" cy="1353312"/>
           </a:xfrm>
           <a:prstGeom prst="rect">
             <a:avLst/>
           </a:prstGeom>
         </p:spPr>
       </p:pic>
+      <p:sp>
+        <p:nvSpPr>
+          <p:cNvPr id="39" name="Shape 29"/>
+          <p:cNvSpPr/>
+          <p:nvPr/>
+        </p:nvSpPr>
+        <p:spPr>
+          <a:xfrm>
+            <a:off x="320040" y="3291840"/>
+            <a:ext cx="1828800" cy="1353312"/>
+          </a:xfrm>
+          <a:prstGeom prst="roundRect">
+            <a:avLst>
+              <a:gd name="adj" fmla="val 8108"/>
+            </a:avLst>
+          </a:prstGeom>
+          <a:ln w="19050">
+            <a:solidFill>
+              <a:srgbClr val="F2A33A"/>
+            </a:solidFill>
+            <a:prstDash val="solid"/>
+          </a:ln>
+        </p:spPr>
+      </p:sp>
       <p:sp>
         <p:nvSpPr>
           <p:cNvPr id="40" name="label"/>
@@ -2224,7 +2234,7 @@
         </p:nvSpPr>
         <p:spPr>
           <a:xfrm>
-            <a:off x="320040" y="3822192"/>
+            <a:off x="320040" y="3895344"/>
             <a:ext cx="1828800" cy="329184"/>
           </a:xfrm>
           <a:prstGeom prst="rect">
@@ -2232,6 +2242,13 @@
           </a:prstGeom>
           <a:noFill/>
           <a:ln/>
+          <a:effectLst>
+            <a:outerShdw sx="100000" sy="100000" kx="0" ky="0" algn="bl" rotWithShape="0" blurRad="76200" dist="19050" dir="5400000">
+              <a:srgbClr val="000000">
+                <a:alpha val="70000"/>
+              </a:srgbClr>
+            </a:outerShdw>
+          </a:effectLst>
         </p:spPr>
         <p:txBody>
           <a:bodyPr wrap="square" lIns="0" tIns="0" rIns="0" bIns="0" rtlCol="0" anchor="ctr"/>
@@ -2263,17 +2280,24 @@
         </p:nvSpPr>
         <p:spPr>
           <a:xfrm>
-            <a:off x="393192" y="4160520"/>
-            <a:ext cx="1682496" cy="438912"/>
+            <a:off x="393192" y="4215384"/>
+            <a:ext cx="1682496" cy="402336"/>
           </a:xfrm>
           <a:prstGeom prst="rect">
             <a:avLst/>
           </a:prstGeom>
           <a:noFill/>
           <a:ln/>
-        </p:spPr>
-        <p:txBody>
-          <a:bodyPr wrap="square" lIns="0" tIns="0" rIns="0" bIns="0" rtlCol="0" anchor="t"/>
+          <a:effectLst>
+            <a:outerShdw sx="100000" sy="100000" kx="0" ky="0" algn="bl" rotWithShape="0" blurRad="76200" dist="19050" dir="5400000">
+              <a:srgbClr val="000000">
+                <a:alpha val="70000"/>
+              </a:srgbClr>
+            </a:outerShdw>
+          </a:effectLst>
+        </p:spPr>
+        <p:txBody>
+          <a:bodyPr wrap="square" lIns="0" tIns="0" rIns="0" bIns="0" rtlCol="0" anchor="ctr"/>
           <a:lstStyle/>
           <a:p>
             <a:pPr algn="ctr" indent="0" marL="0">
@@ -2288,7 +2312,7 @@
                 <a:ea typeface="Calibri" pitchFamily="34" charset="-122"/>
                 <a:cs typeface="Calibri" pitchFamily="34" charset="-120"/>
               </a:rPr>
-              <a:t>Falling water or steam spins a turbine</a:t>
+              <a:t>Wind, falling water or steam spins a turbine</a:t>
             </a:r>
             <a:endParaRPr lang="en-US" sz="1300" dirty="0"/>
           </a:p>

</xml_diff>

<commit_message>
Use the steam power plant photo in the diagram's Power plant card
Replaces the wind turbines with the team's photo of a steam power plant
and its cooling tower. The card text is back to "Falling water or steam
spins a turbine", and the notes explain that the plant's cooling tower
evaporates water (the off-site water from Slide 2).

Co-Authored-By: Claude Opus 5.5 <noreply@anthropic.com>
Claude-Session: https://claude.ai/code/session_01D1yfgr7znJrRSehnJ7HGe8
</commit_message>
<xml_diff>
--- a/ai-diagram-slide.pptx
+++ b/ai-diagram-slide.pptx
@@ -568,13 +568,13 @@
           <a:p>
             <a:r>
               <a:rPr lang="en-US" dirty="0"/>
-              <a:t>Photos: our team's pictures of a dam, wind turbines (power plant), a phone, server racks (behind the data center) and a desalination plant.</a:t>
+              <a:t>Photos: our team's pictures of a dam, a steam power plant with its cooling tower, a phone, server racks (behind the data center) and a desalination plant.</a:t>
             </a:r>
           </a:p>
           <a:p>
             <a:r>
               <a:rPr lang="en-US" dirty="0"/>
-              <a:t>Wind turbines are spun by wind, not water, and use almost no water to make electricity. That is one way to make AI's power less thirsty.</a:t>
+              <a:t>The power plant photo shows a steam plant: it burns fuel to boil water, the steam spins the turbine, and the big cooling tower evaporates water. That evaporated water is the off-site water from Slide 2.</a:t>
             </a:r>
           </a:p>
         </p:txBody>
@@ -2312,7 +2312,7 @@
                 <a:ea typeface="Calibri" pitchFamily="34" charset="-122"/>
                 <a:cs typeface="Calibri" pitchFamily="34" charset="-120"/>
               </a:rPr>
-              <a:t>Wind, falling water or steam spins a turbine</a:t>
+              <a:t>Falling water or steam spins a turbine</a:t>
             </a:r>
             <a:endParaRPr lang="en-US" sz="1300" dirty="0"/>
           </a:p>

</xml_diff>

<commit_message>
Show the dam and the turbine in the diagram's Power plant card
The Power plant card uses the team's hydro power plant picture, made
taller with the text underneath so the dam, the pipe and the turbine all
show. The falling-water arrow and its label move to fit, and the notes
describe the new picture.

Co-Authored-By: Claude Opus 5.5 <noreply@anthropic.com>
Claude-Session: https://claude.ai/code/session_01D1yfgr7znJrRSehnJ7HGe8
</commit_message>
<xml_diff>
--- a/ai-diagram-slide.pptx
+++ b/ai-diagram-slide.pptx
@@ -568,7 +568,7 @@
           <a:p>
             <a:r>
               <a:rPr lang="en-US" dirty="0"/>
-              <a:t>Photos: our team's pictures of a dam, a steam power plant with its cooling tower, a phone, server racks (behind the data center) and a desalination plant.</a:t>
+              <a:t>Photos: our team's pictures of a dam, a hydro power plant (a drawing: water from the dam spins the turbine), a phone, server racks (behind the data center) and a desalination plant.</a:t>
             </a:r>
           </a:p>
           <a:p>
@@ -2178,9 +2178,38 @@
           </a:p>
         </p:txBody>
       </p:sp>
+      <p:sp>
+        <p:nvSpPr>
+          <p:cNvPr id="38" name="Shape 29"/>
+          <p:cNvSpPr/>
+          <p:nvPr/>
+        </p:nvSpPr>
+        <p:spPr>
+          <a:xfrm>
+            <a:off x="320040" y="2880360"/>
+            <a:ext cx="1828800" cy="2340864"/>
+          </a:xfrm>
+          <a:prstGeom prst="roundRect">
+            <a:avLst>
+              <a:gd name="adj" fmla="val 6000"/>
+            </a:avLst>
+          </a:prstGeom>
+          <a:solidFill>
+            <a:srgbClr val="0E1B2A">
+              <a:alpha val="90000"/>
+            </a:srgbClr>
+          </a:solidFill>
+          <a:ln w="19050">
+            <a:solidFill>
+              <a:srgbClr val="F2A33A"/>
+            </a:solidFill>
+            <a:prstDash val="solid"/>
+          </a:ln>
+        </p:spPr>
+      </p:sp>
       <p:pic>
         <p:nvPicPr>
-          <p:cNvPr id="38" name="Image 7" descr="preencoded.png">    </p:cNvPr>
+          <p:cNvPr id="39" name="Image 7" descr="preencoded.png">    </p:cNvPr>
           <p:cNvPicPr>
             <a:picLocks noChangeAspect="1"/>
           </p:cNvPicPr>
@@ -2194,38 +2223,14 @@
         </p:blipFill>
         <p:spPr>
           <a:xfrm>
-            <a:off x="320040" y="3291840"/>
-            <a:ext cx="1828800" cy="1353312"/>
+            <a:off x="393192" y="2953512"/>
+            <a:ext cx="1682496" cy="1554480"/>
           </a:xfrm>
           <a:prstGeom prst="rect">
             <a:avLst/>
           </a:prstGeom>
         </p:spPr>
       </p:pic>
-      <p:sp>
-        <p:nvSpPr>
-          <p:cNvPr id="39" name="Shape 29"/>
-          <p:cNvSpPr/>
-          <p:nvPr/>
-        </p:nvSpPr>
-        <p:spPr>
-          <a:xfrm>
-            <a:off x="320040" y="3291840"/>
-            <a:ext cx="1828800" cy="1353312"/>
-          </a:xfrm>
-          <a:prstGeom prst="roundRect">
-            <a:avLst>
-              <a:gd name="adj" fmla="val 8108"/>
-            </a:avLst>
-          </a:prstGeom>
-          <a:ln w="19050">
-            <a:solidFill>
-              <a:srgbClr val="F2A33A"/>
-            </a:solidFill>
-            <a:prstDash val="solid"/>
-          </a:ln>
-        </p:spPr>
-      </p:sp>
       <p:sp>
         <p:nvSpPr>
           <p:cNvPr id="40" name="label"/>
@@ -2234,7 +2239,7 @@
         </p:nvSpPr>
         <p:spPr>
           <a:xfrm>
-            <a:off x="320040" y="3895344"/>
+            <a:off x="320040" y="4544568"/>
             <a:ext cx="1828800" cy="329184"/>
           </a:xfrm>
           <a:prstGeom prst="rect">
@@ -2242,13 +2247,6 @@
           </a:prstGeom>
           <a:noFill/>
           <a:ln/>
-          <a:effectLst>
-            <a:outerShdw sx="100000" sy="100000" kx="0" ky="0" algn="bl" rotWithShape="0" blurRad="76200" dist="19050" dir="5400000">
-              <a:srgbClr val="000000">
-                <a:alpha val="70000"/>
-              </a:srgbClr>
-            </a:outerShdw>
-          </a:effectLst>
         </p:spPr>
         <p:txBody>
           <a:bodyPr wrap="square" lIns="0" tIns="0" rIns="0" bIns="0" rtlCol="0" anchor="ctr"/>
@@ -2280,21 +2278,14 @@
         </p:nvSpPr>
         <p:spPr>
           <a:xfrm>
-            <a:off x="393192" y="4215384"/>
-            <a:ext cx="1682496" cy="402336"/>
+            <a:off x="393192" y="4846320"/>
+            <a:ext cx="1682496" cy="347472"/>
           </a:xfrm>
           <a:prstGeom prst="rect">
             <a:avLst/>
           </a:prstGeom>
           <a:noFill/>
           <a:ln/>
-          <a:effectLst>
-            <a:outerShdw sx="100000" sy="100000" kx="0" ky="0" algn="bl" rotWithShape="0" blurRad="76200" dist="19050" dir="5400000">
-              <a:srgbClr val="000000">
-                <a:alpha val="70000"/>
-              </a:srgbClr>
-            </a:outerShdw>
-          </a:effectLst>
         </p:spPr>
         <p:txBody>
           <a:bodyPr wrap="square" lIns="0" tIns="0" rIns="0" bIns="0" rtlCol="0" anchor="ctr"/>
@@ -2595,7 +2586,7 @@
         <p:spPr>
           <a:xfrm>
             <a:off x="1234440" y="2368296"/>
-            <a:ext cx="18288" cy="886968"/>
+            <a:ext cx="18288" cy="475488"/>
           </a:xfrm>
           <a:custGeom>
             <a:avLst/>
@@ -2604,12 +2595,12 @@
             <a:cxnLst/>
             <a:rect l="l" t="t" r="r" b="b"/>
             <a:pathLst>
-              <a:path w="18288" h="886968">
+              <a:path w="18288" h="475488">
                 <a:moveTo>
                   <a:pt x="0" y="0"/>
                 </a:moveTo>
                 <a:lnTo>
-                  <a:pt x="0" y="886968"/>
+                  <a:pt x="0" y="475488"/>
                 </a:lnTo>
               </a:path>
             </a:pathLst>
@@ -2632,8 +2623,8 @@
         </p:nvSpPr>
         <p:spPr>
           <a:xfrm>
-            <a:off x="1325880" y="2670048"/>
-            <a:ext cx="1051560" cy="274320"/>
+            <a:off x="137160" y="2487168"/>
+            <a:ext cx="1024128" cy="274320"/>
           </a:xfrm>
           <a:prstGeom prst="rect">
             <a:avLst/>
@@ -2645,7 +2636,7 @@
           <a:bodyPr wrap="square" lIns="0" tIns="0" rIns="0" bIns="0" rtlCol="0" anchor="ctr"/>
           <a:lstStyle/>
           <a:p>
-            <a:pPr algn="l" indent="0" marL="0">
+            <a:pPr algn="r" indent="0" marL="0">
               <a:buNone/>
             </a:pPr>
             <a:r>
@@ -3610,8 +3601,8 @@
         </p:nvSpPr>
         <p:spPr>
           <a:xfrm>
-            <a:off x="1234440" y="4681728"/>
-            <a:ext cx="4489704" cy="1353312"/>
+            <a:off x="1234440" y="5257800"/>
+            <a:ext cx="4489704" cy="777240"/>
           </a:xfrm>
           <a:custGeom>
             <a:avLst/>
@@ -3620,15 +3611,15 @@
             <a:cxnLst/>
             <a:rect l="l" t="t" r="r" b="b"/>
             <a:pathLst>
-              <a:path w="4489704" h="1353312">
+              <a:path w="4489704" h="777240">
                 <a:moveTo>
                   <a:pt x="0" y="0"/>
                 </a:moveTo>
                 <a:lnTo>
-                  <a:pt x="0" y="1353312"/>
+                  <a:pt x="0" y="777240"/>
                 </a:lnTo>
                 <a:lnTo>
-                  <a:pt x="4489704" y="1353312"/>
+                  <a:pt x="4489704" y="777240"/>
                 </a:lnTo>
               </a:path>
             </a:pathLst>

</xml_diff>